<commit_message>
Regenerate deck with live demo link
</commit_message>
<xml_diff>
--- a/deck/Climate_Intelligence_Challenge_Deck.pptx
+++ b/deck/Climate_Intelligence_Challenge_Deck.pptx
@@ -3181,6 +3181,41 @@
         </p:nvSpPr>
         <p:spPr>
           <a:xfrm>
+            <a:off x="731520" y="3931920"/>
+            <a:ext cx="10698480" cy="457200"/>
+          </a:xfrm>
+          <a:prstGeom prst="rect">
+            <a:avLst/>
+          </a:prstGeom>
+          <a:noFill/>
+        </p:spPr>
+        <p:txBody>
+          <a:bodyPr wrap="square">
+            <a:spAutoFit/>
+          </a:bodyPr>
+          <a:lstStyle/>
+          <a:p>
+            <a:pPr algn="l"/>
+            <a:r>
+              <a:rPr sz="1700" b="1">
+                <a:solidFill>
+                  <a:srgbClr val="66BB6A"/>
+                </a:solidFill>
+                <a:latin typeface="Calibri"/>
+              </a:rPr>
+              <a:t>Live demo: ather-hackathon.streamlit.app</a:t>
+            </a:r>
+          </a:p>
+        </p:txBody>
+      </p:sp>
+      <p:sp>
+        <p:nvSpPr>
+          <p:cNvPr id="5" name="TextBox 4"/>
+          <p:cNvSpPr txBox="1"/>
+          <p:nvPr/>
+        </p:nvSpPr>
+        <p:spPr>
+          <a:xfrm>
             <a:off x="731520" y="5760720"/>
             <a:ext cx="10698480" cy="457200"/>
           </a:xfrm>
@@ -6019,7 +6054,7 @@
                 </a:solidFill>
                 <a:latin typeface="Calibri"/>
               </a:rPr>
-              <a:t>Live link: &lt;INSERT STREAMLIT APP URL HERE&gt;</a:t>
+              <a:t>Live link: https://ather-hackathon.streamlit.app/</a:t>
             </a:r>
           </a:p>
         </p:txBody>
@@ -6054,7 +6089,7 @@
                 </a:solidFill>
                 <a:latin typeface="Calibri"/>
               </a:rPr>
-              <a:t>GitHub: &lt;INSERT REPO URL HERE&gt;</a:t>
+              <a:t>GitHub: https://github.com/Laveshjadon/ATHER-HACKATHON</a:t>
             </a:r>
           </a:p>
         </p:txBody>

</xml_diff>